<commit_message>
Polish remaining judgment framing and strip 友商 action tails
Co-authored-by: Annie <Annie-Summer@users.noreply.github.com>
</commit_message>
<xml_diff>
--- a/yunqi-2026-pai-forum/docs/洞察一页-06-企业工程化AI提效：知识、流程和智能系统.pptx
+++ b/yunqi-2026-pai-forum/docs/洞察一页-06-企业工程化AI提效：知识、流程和智能系统.pptx
@@ -3323,7 +3323,7 @@
                 <a:latin typeface="Microsoft YaHei"/>
                 <a:ea typeface="Microsoft YaHei"/>
               </a:rPr>
-              <a:t>一句话判断：CARIAD 知识、流程和智能系统——LLM的概率性本质与汽车软件工程对规模、复杂度、协作与稳定产出的刚性要求。演讲给出CEA AI效能平台三层架构（模型服务 / HARNESS / 业务应用），并以整车故障归因系统证明：用知识骨架引导符号推理，才能把Agent从演示变成可审计、可版本管理的工程资产。</a:t>
+              <a:t>一句话判断：CARIAD 知识、流程和智能系统——LLM的概率性本质与汽车软件工程对规模、复杂度、协作与稳定产出的刚性要求。CEA AI效能平台三层架构（模型服务 / HARNESS / 业务应用），并以整车故障归因系统证明：用知识骨架引导符号推理，才能把Agent从演示变成可审计、可版本管理的工程资产。</a:t>
             </a:r>
           </a:p>
         </p:txBody>
@@ -3788,7 +3788,7 @@
                 <a:latin typeface="Microsoft YaHei"/>
                 <a:ea typeface="Microsoft YaHei"/>
               </a:rPr>
-              <a:t>高价值场景应「流程嵌入优先」：工单系统、IM、本体、代码图谱与Agent同闭环</a:t>
+              <a:t>高价值场景应「流程嵌入优先」：工单系统、IM、本体、代码图谱与Agent同闭环。</a:t>
             </a:r>
           </a:p>
           <a:p>

</xml_diff>

<commit_message>
Rebuild insight PPTs after 友商/HCS framing cleanup
Co-authored-by: Annie <Annie-Summer@users.noreply.github.com>
</commit_message>
<xml_diff>
--- a/yunqi-2026-pai-forum/docs/洞察一页-06-企业工程化AI提效：知识、流程和智能系统.pptx
+++ b/yunqi-2026-pai-forum/docs/洞察一页-06-企业工程化AI提效：知识、流程和智能系统.pptx
@@ -3444,7 +3444,7 @@
                 <a:latin typeface="Microsoft YaHei"/>
                 <a:ea typeface="Microsoft YaHei"/>
               </a:rPr>
-              <a:t>友商若只做「个人Copilot渗透率」，难以过企级验收</a:t>
+              <a:t>只做「个人Copilot渗透率」，难以过企级验收</a:t>
             </a:r>
           </a:p>
           <a:p>
@@ -4872,7 +4872,7 @@
                 <a:latin typeface="Microsoft YaHei"/>
                 <a:ea typeface="Microsoft YaHei"/>
               </a:rPr>
-              <a:t>启示要点：企业工程化AI的胜负手不是单点模型，而是「知识骨架 + MCP工具原子化 + Agent分工 + 合规横切」；汽车软件场景证明：RAG/本体/代码图谱与多Agent流水线结合，可将定界与定位压缩到约20分钟量级；</a:t>
+              <a:t>启示要点：企业工程化AI的胜负手不是单点模型，而是「知识骨架 + MCP工具原子化 + Agent分工 + 合规横切」；汽车软件场景证明：RAG/本体/代码图谱与多Agent流水线结合，可将定界与定位压缩到约20分钟量级。</a:t>
             </a:r>
           </a:p>
         </p:txBody>

</xml_diff>